<commit_message>
📰 Pulse update 2026-03-13
</commit_message>
<xml_diff>
--- a/data/archive/pulse_2026-03-13.pptx
+++ b/data/archive/pulse_2026-03-13.pptx
@@ -4030,11 +4030,11 @@
               </a:defRPr>
             </a:pPr>
             <a:r>
-              <a:t>*Hi &lt;!here&gt;! Our Connect Groups Spring Season is open!* :seedling::celebrate:</a:t>
+              <a:t>_Hi everyone &lt;!channel&gt;_ :wave:</a:t>
             </a:r>
             <a:br/>
             <a:r>
-              <a:t>Co...</a:t>
+              <a:t>_I recorded a short video showing how I built a ...</a:t>
             </a:r>
           </a:p>
         </p:txBody>
@@ -4070,15 +4070,19 @@
               </a:defRPr>
             </a:pPr>
             <a:r>
-              <a:t>"*Hi &lt;!here&gt;! Our Connect Groups Spring Season is open!* :seedling::celebrate:</a:t>
+              <a:t>"_Hi everyone &lt;!channel&gt;_ :wave:</a:t>
             </a:r>
             <a:br/>
             <a:r>
-              <a:t>Connect Groups at Appodeal run in *seasons*, and we’re now officially entering the *Spring Season (March–May)!* :blossom::tulip::seedling:</a:t>
+              <a:t>_I recorded a short video showing how I built a fully automated AI-powered system — from idea to production — using only AI tools and zero coding experience._</a:t>
             </a:r>
             <a:br/>
             <a:r>
-              <a:t>If you’re new: Connect Groups are *&lt;https://appodeal.circle.so/c/welcome/|employee-"</a:t>
+              <a:t>_Slack data → AI curation → auto-deploying a live dashboard on office TVs. All running on autopilot._</a:t>
+            </a:r>
+            <a:br/>
+            <a:r>
+              <a:t>_If I c"</a:t>
             </a:r>
           </a:p>
         </p:txBody>
@@ -4114,7 +4118,7 @@
               </a:defRPr>
             </a:pPr>
             <a:r>
-              <a:t>— Katarzyna Raniszewska</a:t>
+              <a:t>— Liliya Garifullina</a:t>
             </a:r>
           </a:p>
         </p:txBody>

</xml_diff>